<commit_message>
RASS page: refresh the slides to the current deck (larger slide-2 charts)
Co-Authored-By: Claude Opus 5.5 <noreply@anthropic.com>
</commit_message>
<xml_diff>
--- a/RASS/slides/RASS_NeurIPS2026_talk.pptx
+++ b/RASS/slides/RASS_NeurIPS2026_talk.pptx
@@ -117,22 +117,22 @@
   <p:extLst>
     <p:ext uri="{521415D9-36F7-43E2-AB2F-B90AF26B5E84}">
       <p14:sectionLst xmlns:p14="http://schemas.microsoft.com/office/powerpoint/2010/main">
-        <p14:section name="Opening" id="{5c4c055a-d664-25ec-412b-c238b248ca29}">
+        <p14:section name="Opening" id="{f2c6bb66-2741-bc54-dd82-8a5c69a0e20d}">
           <p14:sldIdLst>
             <p14:sldId id="256"/>
           </p14:sldIdLst>
         </p14:section>
-        <p14:section name="Problem" id="{e5ff5a0c-218a-4b42-130f-eb07a8bf7c8c}">
+        <p14:section name="Problem" id="{38c5eaa1-e9e1-b0be-5831-e91164741bd4}">
           <p14:sldIdLst>
             <p14:sldId id="257"/>
           </p14:sldIdLst>
         </p14:section>
-        <p14:section name="Method" id="{9d51b4c3-ed8f-e361-f643-5f0dfd327b52}">
+        <p14:section name="Method" id="{8bb0d537-ae02-154a-7a17-0e1bc8617d45}">
           <p14:sldIdLst>
             <p14:sldId id="258"/>
           </p14:sldIdLst>
         </p14:section>
-        <p14:section name="Results" id="{f8483f5f-3d3e-9f68-212c-74a85b1c0a48}">
+        <p14:section name="Results" id="{da67f404-a125-e4a1-863b-ff68f500612e}">
           <p14:sldIdLst>
             <p14:sldId id="259"/>
             <p14:sldId id="260"/>
@@ -140,14 +140,14 @@
             <p14:sldId id="262"/>
           </p14:sldIdLst>
         </p14:section>
-        <p14:section name="Extensions" id="{4468491b-ae89-0ed6-afb3-0f894dff1cff}">
+        <p14:section name="Extensions" id="{e2736ad6-1413-2097-d967-84bc63fecd1f}">
           <p14:sldIdLst>
             <p14:sldId id="263"/>
             <p14:sldId id="264"/>
             <p14:sldId id="265"/>
           </p14:sldIdLst>
         </p14:section>
-        <p14:section name="Closing" id="{006e9f6f-8b34-a3aa-90bb-47040a00dd5c}">
+        <p14:section name="Closing" id="{28ee3347-31ea-c2b3-01a0-b04ac74d9e24}">
           <p14:sldIdLst>
             <p14:sldId id="266"/>
           </p14:sldIdLst>
@@ -2465,7 +2465,7 @@
           <a:p>
             <a:r>
               <a:rPr lang="en-US" dirty="0"/>
-              <a:t>What if you could benchmark on 48 scenes instead of 3,521, with a statistical audit behind that choice? Hello, I'm Ahmad AlMughrabi from the University of Barcelona, presenting RASS, joint work with Flavià Serret, Ricardo Marques and Petia Radeva.</a:t>
+              <a:t>What if you could benchmark on 48 food scenes instead of 3,521, with a statistical audit behind that choice? Hello, I'm Ahmad AlMughrabi from the University of Barcelona, presenting RASS, joint work with Flavià Serret, Ricardo Marques and Petia Radeva.</a:t>
             </a:r>
             <a:endParaRPr lang="en-US" dirty="0"/>
           </a:p>
@@ -2553,7 +2553,7 @@
           <a:p>
             <a:r>
               <a:rPr lang="en-US" dirty="0"/>
-              <a:t>And the protocol transfers: on DL3DV, a contract re-declared for that dataset certifies 64 of 140 scenes for four methods.</a:t>
+              <a:t>And the protocol transfers: on DL3DV, with tolerances re-declared for that dataset, it certifies 64 of 140 scenes for four methods.</a:t>
             </a:r>
             <a:endParaRPr lang="en-US" dirty="0"/>
           </a:p>
@@ -2641,7 +2641,7 @@
           <a:p>
             <a:r>
               <a:rPr lang="en-US" dirty="0"/>
-              <a:t>To use RASS, train on RASS-48 to screen ideas or on RASS-96 to report results, and compare with our released logs on the same scenes. The guarantee is global, and neither subset replaces a full leaderboard. Everything is released, so you can rerun the audit for your own methods. So next time you shrink a benchmark, audit it. Thank you.</a:t>
+              <a:t>To use RASS, train on RASS-48 to screen ideas or on RASS-96 to report results, and compare with our released logs on the same scenes. Neither replaces a full leaderboard. Everything is released, so you can rerun the audit for your own methods. So next time you shrink a benchmark, audit it. Thank you.</a:t>
             </a:r>
             <a:endParaRPr lang="en-US" dirty="0"/>
           </a:p>
@@ -2729,7 +2729,7 @@
           <a:p>
             <a:r>
               <a:rPr lang="en-US" dirty="0"/>
-              <a:t>NeRF methods are trained per scene, so every ablation on our full benchmark means 3,521 trainings; producing the full logs once took a supercomputer with up to 512 H100 GPUs. So people evaluate on small ad hoc subsets, which can look right for the wrong reasons. These are real 48-scene draws: one matches every mean, yet its LPIPS distribution drifts; another matches PSNR almost exactly, while SSIM and LPIPS miss. And any single pass may be luck. So we ask: what is the smallest subset that preserves the full-benchmark summaries under explicit constraints?</a:t>
+              <a:t>NeRF methods train one model per scene. So one ablation on our benchmark means 3,521 trainings, and producing those logs once took a supercomputer with up to 512 H100 GPUs. Small ad hoc subsets can look right for the wrong reasons. Top, a real draw: all three image-quality means match, but the amber LPIPS curve drifts. That's tail shift. Middle: PSNR matches, but SSIM and LPIPS overshoot. That's metric leakage. Bottom: one pass may just be luck. So, what is the smallest subset that keeps the full-benchmark summaries?</a:t>
             </a:r>
             <a:endParaRPr lang="en-US" dirty="0"/>
           </a:p>
@@ -2817,7 +2817,7 @@
           <a:p>
             <a:r>
               <a:rPr lang="en-US" dirty="0"/>
-              <a:t>RASS answers with an audit. We describe each scene with 57 descriptors and cluster the scenes into six regimes. For each budget, a generator draws 400 candidate subsets, here with equal scenes per regime. Each candidate must pass six constraints at once: the PSNR, SSIM and LPIPS means within tolerance, and a Kolmogorov-Smirnov bound on each distribution. Against luck, we audit the pass rate of the procedure, not a single subset. Once a budget is certified, we export one passing draw by a fixed rule and validate it on its own. All of this runs on existing logs, on a CPU.</a:t>
+              <a:t>RASS answers with an audit. We describe each scene with 57 descriptors and cluster the scenes into six regimes. For each budget, meaning subset size, a balanced generator draws 400 candidates, with equal scenes per regime. Each candidate must pass six checks at once. The mean tolerances guard against leakage; a Kolmogorov-Smirnov, or KS, bound on each distribution guards against tail shift. Against luck, we audit the procedure: a 95% Wilson lower bound on its pass rate must clear a target, p-min. Budgets that clear it are certified, and we recommend the smallest. We then release one passing draw, chosen by a fixed rule, and validate it separately.</a:t>
             </a:r>
             <a:endParaRPr lang="en-US" dirty="0"/>
           </a:p>
@@ -2905,7 +2905,7 @@
           <a:p>
             <a:r>
               <a:rPr lang="en-US" dirty="0"/>
-              <a:t>Here are the 400 real draws at 48 scenes. 88 pass all six constraints, a pass rate of 0.22; the seven amber ones matched every mean but failed the KS bound. The 95% Wilson lower bound, a pessimistic pass rate, is 0.182, above our target of 0.08, so the 48-scene budget is certified. The target is a yield: on average, at most about twelve cheap log checks find a passing subset.</a:t>
+              <a:t>Take one budget, 48 scenes: here are its 400 real draws. Teal: 88 pass all six. Amber: seven match every mean but fail KS, so the tail shift is caught. Grey: the rest miss a mean. Pass rate: 0.22. Even the pessimistic lower bound, 0.182, clears p-min of 0.08, so the 48-scene budget is certified. Read p-min as a yield: on average, at most twelve and a half cheap log checks find a passing subset.</a:t>
             </a:r>
             <a:endParaRPr lang="en-US" dirty="0"/>
           </a:p>
@@ -2993,7 +2993,7 @@
           <a:p>
             <a:r>
               <a:rPr lang="en-US" dirty="0"/>
-              <a:t>Repeating this for each budget on our grid gives the cost-reliability frontier. Teal is the pass rate; red is its lower bound. With the target at 0.08, the smallest evaluated budget is 48 scenes: RASS-48, our screening subset for ablations.</a:t>
+              <a:t>Repeating this for every budget on our grid gives the cost-reliability frontier. Teal is the pass rate; red is its lower bound. With the target at 0.08, the bound clears it at 48 scenes, our smallest evaluated budget: RASS-48, for screening and ablations.</a:t>
             </a:r>
             <a:endParaRPr lang="en-US" dirty="0"/>
           </a:p>
@@ -3081,7 +3081,7 @@
           <a:p>
             <a:r>
               <a:rPr lang="en-US" dirty="0"/>
-              <a:t>Raise the target to 0.20, and the lower bound first clears it at 96 scenes: RASS-96. It costs twice the scenes but carries a stronger guarantee, so we recommend it for results you report. You pick the point on the frontier that matches the reliability you need.</a:t>
+              <a:t>Raise the target to 0.20, and the bound first clears it at 96 scenes: RASS-96. It costs twice the scenes but carries a stronger guarantee, so we recommend it for results you report. Pick the reliability you need.</a:t>
             </a:r>
             <a:endParaRPr lang="en-US" dirty="0"/>
           </a:p>
@@ -3169,7 +3169,7 @@
           <a:p>
             <a:r>
               <a:rPr lang="en-US" dirty="0"/>
-              <a:t>We then check the exported RASS-48 subset itself. Each bar is the share of a tolerance it uses, and all six stay below the limit; the closest is the LPIPS KS distance, at 80 percent. That is 73 times fewer scenes than the full benchmark, eight from each regime. The guarantee is global: we do not claim per-regime fidelity.</a:t>
+              <a:t>Back to RASS-48: now we check the released subset itself. Each bar shows how much of its tolerance the subset uses. All six stay under the limit; the closest, LPIPS KS, uses 80 percent. That's 73 times fewer scenes than the full benchmark, eight from each regime. The guarantee is global: the whole benchmark, not each regime.</a:t>
             </a:r>
             <a:endParaRPr lang="en-US" dirty="0"/>
           </a:p>
@@ -3257,7 +3257,7 @@
           <a:p>
             <a:r>
               <a:rPr lang="en-US" dirty="0"/>
-              <a:t>The audit extends to several methods at once. In joint audits, RASS-48 passes 14 of 16 constraints for three methods, while RASS-96 passes all 16, and all 22 with nerfacto added.</a:t>
+              <a:t>So far, everything used one method's logs, Zip-NeRF. In a joint audit, every method must pass on the same subset. For three methods, RASS-48 passes 14 of 16 checks. RASS-96 passes all 16, and all 22 with nerfacto added.</a:t>
             </a:r>
             <a:endParaRPr lang="en-US" dirty="0"/>
           </a:p>
@@ -3345,7 +3345,7 @@
           <a:p>
             <a:r>
               <a:rPr lang="en-US" dirty="0"/>
-              <a:t>Any generator plugs in. Random and balanced sampling certify at 48 scenes and facility location at 36, though its reimplementation is unstable across seeds, and balanced sampling also passes at 36 on an extended grid. k-center coverage fails up to 96 scenes, so coverage alone is not fidelity.</a:t>
+              <a:t>We can also swap the subset generator. Facility location, a diversity selector, certifies at 36 scenes, but our re-run of it is unstable across seeds. Balanced and random sampling certify at 48, and k-center coverage fails up to 96: coverage alone is not fidelity.</a:t>
             </a:r>
             <a:endParaRPr lang="en-US" dirty="0"/>
           </a:p>

</xml_diff>